<commit_message>
Final changes prior to exam.
</commit_message>
<xml_diff>
--- a/exam/exam.pptx
+++ b/exam/exam.pptx
@@ -4012,7 +4012,7 @@
         <p:spPr>
           <a:xfrm>
             <a:off x="6378060" y="1658405"/>
-            <a:ext cx="1212783" cy="1754326"/>
+            <a:ext cx="1890041" cy="1754326"/>
           </a:xfrm>
           <a:prstGeom prst="rect">
             <a:avLst/>
@@ -4034,7 +4034,7 @@
                   </a:schemeClr>
                 </a:solidFill>
               </a:rPr>
-              <a:t>Dårligt</a:t>
+              <a:t>Mindre godt</a:t>
             </a:r>
           </a:p>
           <a:p>
@@ -4198,7 +4198,7 @@
                   </a:schemeClr>
                 </a:solidFill>
               </a:rPr>
-              <a:t>Systemudvikling</a:t>
+              <a:t>Systemudvikling (1-mandsgruppe også)</a:t>
             </a:r>
           </a:p>
           <a:p>

</xml_diff>